<commit_message>
docs: recompile PDF and HTML reports with live Render cloud API and GitHub Pages deployment endpoints
</commit_message>
<xml_diff>
--- a/docs/presentation.pptx
+++ b/docs/presentation.pptx
@@ -6880,7 +6880,7 @@
               </a:defRPr>
             </a:pPr>
             <a:r>
-              <a:t>Enterprise Web Translation Studio (web/index.html)</a:t>
+              <a:t>Live Web Studio &amp; Cloud API Ecosystem</a:t>
             </a:r>
           </a:p>
           <a:p>
@@ -6892,10 +6892,18 @@
               </a:defRPr>
             </a:pPr>
             <a:r>
-              <a:t>• Responsive glassmorphism interface with instant typing reactivity.</a:t>
+              <a:t>• Live Web Studio on GitHub Pages: https://chaitanya-thurangi.github.io/NormMix/</a:t>
             </a:r>
             <a:br/>
             <a:r>
+              <a:t>• Live Neural API Backend on Render: https://normmix-api.onrender.com (FastAPI Docker).</a:t>
+            </a:r>
+            <a:br/>
+            <a:r>
+              <a:t>• Hybrid Dual-Engine Architecture: 5s cloud timeout + 0ms client fallback in browser.</a:t>
+            </a:r>
+            <a:br/>
+            <a:r>
               <a:t>• Real-time Google Input Tools style phonetic suggestions dropdown (1. నాకు 2. నాకూ 3. నకు).</a:t>
             </a:r>
             <a:br/>
@@ -6904,15 +6912,7 @@
             </a:r>
             <a:br/>
             <a:r>
-              <a:t>• Virtual Telugu on-screen keyboard drawer with vowels, consonants, and guninthalu matras.</a:t>
-            </a:r>
-            <a:br/>
-            <a:r>
-              <a:t>• Active Learning feedback loop (👍 / 👎) logging user corrections to data/feedback.jsonl.</a:t>
-            </a:r>
-            <a:br/>
-            <a:r>
-              <a:t>• 1-Click WhatsApp export and downloadable text file generation.</a:t>
+              <a:t>• Active Learning feedback loop (👍 / 👎) with real-time continuous fine-tuning on GPU.</a:t>
             </a:r>
           </a:p>
         </p:txBody>
@@ -6995,7 +6995,7 @@
               </a:defRPr>
             </a:pPr>
             <a:r>
-              <a:t>Manifest V3 Browser Extension (chrome-extension/)</a:t>
+              <a:t>Manifest V3 Browser Extension (v0.5.0 Release)</a:t>
             </a:r>
           </a:p>
           <a:p>
@@ -7007,23 +7007,27 @@
               </a:defRPr>
             </a:pPr>
             <a:r>
-              <a:t>• Production browser extension supporting Google Chrome and Microsoft Edge.</a:t>
+              <a:t>• Released via GitHub Releases as an installable package (v0.5.0 ZIP).</a:t>
             </a:r>
             <a:br/>
             <a:r>
-              <a:t>• Popup quick-translator for rapid text normalization without leaving the current tab.</a:t>
+              <a:t>• Universal In-Page Support: Works on WhatsApp Web, Twitter/X, LinkedIn, and Gmail.</a:t>
             </a:r>
             <a:br/>
             <a:r>
-              <a:t>• Context Menu integration: Right-click selected text on WhatsApp Web, Twitter, LinkedIn, or Gmail.</a:t>
+              <a:t>• Dedicated popup translator with all synchronized view modalities and feedback bar.</a:t>
             </a:r>
             <a:br/>
             <a:r>
-              <a:t>• In-page DOM replacement: Normalizes text inside active input fields and textareas seamlessly.</a:t>
+              <a:t>• Context Menu: Right-click selected text to normalize/transliterate instantly in-place.</a:t>
             </a:r>
             <a:br/>
             <a:r>
-              <a:t>• Background Service Worker with offline rule baseline fallback for zero-downtime operation.</a:t>
+              <a:t>• In-Browser Fallback Engine: Zero-downtime operation even during network disconnects.</a:t>
+            </a:r>
+            <a:br/>
+            <a:r>
+              <a:t>• Verified with 62 passing automated unit and integration tests across the framework.</a:t>
             </a:r>
           </a:p>
         </p:txBody>

</xml_diff>